<commit_message>
Update slide 14 + add processed backfill script
- Slide 14: remove Mobile App and ML (already built), add Heat Maps, Push Alerts, Rav-Kav integration, auto reports
- Add fix_backfill_processed.py: fills processed/ paths + train data (276K bus + 207K train records)

Co-Authored-By: Claude Opus 4.6 <noreply@anthropic.com>
</commit_message>
<xml_diff>
--- a/docs/Israel_Transit_Project_Presentation.pptx
+++ b/docs/Israel_Transit_Project_Presentation.pptx
@@ -8749,7 +8749,7 @@
             <a:avLst/>
           </a:prstGeom>
           <a:solidFill>
-            <a:srgbClr val="FFFFFF"/>
+            <a:srgbClr val="F5F5F5"/>
           </a:solidFill>
           <a:ln w="12700">
             <a:solidFill>
@@ -8810,7 +8810,7 @@
               </a:defRPr>
             </a:pPr>
             <a:r>
-              <a:t>🤖</a:t>
+              <a:t>🗺️</a:t>
             </a:r>
           </a:p>
         </p:txBody>
@@ -8846,7 +8846,7 @@
               </a:defRPr>
             </a:pPr>
             <a:r>
-              <a:t>ML Predictions</a:t>
+              <a:t>Heat Maps</a:t>
             </a:r>
           </a:p>
         </p:txBody>
@@ -8882,7 +8882,7 @@
               </a:defRPr>
             </a:pPr>
             <a:r>
-              <a:t>מודל ML לחיזוי איחורים על בסיס היסטוריה + תנועה</a:t>
+              <a:t>מפת חום של עומסי תנועה לפי שעה ויום בשבוע — זיהוי צווארי בקבוק</a:t>
             </a:r>
           </a:p>
         </p:txBody>
@@ -8902,7 +8902,7 @@
             <a:avLst/>
           </a:prstGeom>
           <a:solidFill>
-            <a:srgbClr val="FFFFFF"/>
+            <a:srgbClr val="F5F5F5"/>
           </a:solidFill>
           <a:ln w="12700">
             <a:solidFill>
@@ -8963,7 +8963,7 @@
               </a:defRPr>
             </a:pPr>
             <a:r>
-              <a:t>🗺️</a:t>
+              <a:t>🔔</a:t>
             </a:r>
           </a:p>
         </p:txBody>
@@ -8999,7 +8999,7 @@
               </a:defRPr>
             </a:pPr>
             <a:r>
-              <a:t>Heat Maps</a:t>
+              <a:t>Real-time Push Alerts</a:t>
             </a:r>
           </a:p>
         </p:txBody>
@@ -9035,7 +9035,7 @@
               </a:defRPr>
             </a:pPr>
             <a:r>
-              <a:t>מפת חום של עומסי תנועה לפי שעה ויום</a:t>
+              <a:t>התראות Push למשתמשים על שיבושים וביטולים בקווים שלהם</a:t>
             </a:r>
           </a:p>
         </p:txBody>
@@ -9055,7 +9055,7 @@
             <a:avLst/>
           </a:prstGeom>
           <a:solidFill>
-            <a:srgbClr val="FFFFFF"/>
+            <a:srgbClr val="F5F5F5"/>
           </a:solidFill>
           <a:ln w="12700">
             <a:solidFill>
@@ -9116,7 +9116,7 @@
               </a:defRPr>
             </a:pPr>
             <a:r>
-              <a:t>🔔</a:t>
+              <a:t>📈</a:t>
             </a:r>
           </a:p>
         </p:txBody>
@@ -9152,7 +9152,7 @@
               </a:defRPr>
             </a:pPr>
             <a:r>
-              <a:t>Real-time Push Alerts</a:t>
+              <a:t>Redshift / BigQuery</a:t>
             </a:r>
           </a:p>
         </p:txBody>
@@ -9188,7 +9188,7 @@
               </a:defRPr>
             </a:pPr>
             <a:r>
-              <a:t>התראות Push למשתמשים על שיבושים בקווים שלהם</a:t>
+              <a:t>מחסן נתונים בענן לניתוחים ארוכי טווח ודוחות BI</a:t>
             </a:r>
           </a:p>
         </p:txBody>
@@ -9208,7 +9208,7 @@
             <a:avLst/>
           </a:prstGeom>
           <a:solidFill>
-            <a:srgbClr val="FFFFFF"/>
+            <a:srgbClr val="F5F5F5"/>
           </a:solidFill>
           <a:ln w="12700">
             <a:solidFill>
@@ -9269,7 +9269,7 @@
               </a:defRPr>
             </a:pPr>
             <a:r>
-              <a:t>📈</a:t>
+              <a:t>🌍</a:t>
             </a:r>
           </a:p>
         </p:txBody>
@@ -9305,7 +9305,7 @@
               </a:defRPr>
             </a:pPr>
             <a:r>
-              <a:t>Redshift / BigQuery</a:t>
+              <a:t>כיסוי ארצי</a:t>
             </a:r>
           </a:p>
         </p:txBody>
@@ -9341,7 +9341,7 @@
               </a:defRPr>
             </a:pPr>
             <a:r>
-              <a:t>מחסן נתונים בענן לניתוחים ארוכי טווח</a:t>
+              <a:t>הרחבה מגוש דן לכל הארץ — חיפה, ירושלים, באר שבע</a:t>
             </a:r>
           </a:p>
         </p:txBody>
@@ -9361,7 +9361,7 @@
             <a:avLst/>
           </a:prstGeom>
           <a:solidFill>
-            <a:srgbClr val="FFFFFF"/>
+            <a:srgbClr val="F5F5F5"/>
           </a:solidFill>
           <a:ln w="12700">
             <a:solidFill>
@@ -9422,7 +9422,7 @@
               </a:defRPr>
             </a:pPr>
             <a:r>
-              <a:t>🌍</a:t>
+              <a:t>🎫</a:t>
             </a:r>
           </a:p>
         </p:txBody>
@@ -9458,7 +9458,7 @@
               </a:defRPr>
             </a:pPr>
             <a:r>
-              <a:t>All-Israel Coverage</a:t>
+              <a:t>אינטגרציית רב-קו</a:t>
             </a:r>
           </a:p>
         </p:txBody>
@@ -9494,7 +9494,7 @@
               </a:defRPr>
             </a:pPr>
             <a:r>
-              <a:t>הרחבה מגוש דן לכל הארץ + ערים נוספות</a:t>
+              <a:t>חיבור למערכת רב-קו לנתוני נוסעים ותפוסה בזמן אמת</a:t>
             </a:r>
           </a:p>
         </p:txBody>
@@ -9514,7 +9514,7 @@
             <a:avLst/>
           </a:prstGeom>
           <a:solidFill>
-            <a:srgbClr val="FFFFFF"/>
+            <a:srgbClr val="F5F5F5"/>
           </a:solidFill>
           <a:ln w="12700">
             <a:solidFill>
@@ -9575,7 +9575,7 @@
               </a:defRPr>
             </a:pPr>
             <a:r>
-              <a:t>📱</a:t>
+              <a:t>📊</a:t>
             </a:r>
           </a:p>
         </p:txBody>
@@ -9611,7 +9611,7 @@
               </a:defRPr>
             </a:pPr>
             <a:r>
-              <a:t>Native Mobile App</a:t>
+              <a:t>דוחות אוטומטיים</a:t>
             </a:r>
           </a:p>
         </p:txBody>
@@ -9647,7 +9647,7 @@
               </a:defRPr>
             </a:pPr>
             <a:r>
-              <a:t>React Native / Flutter ל-iOS ו-Android</a:t>
+              <a:t>דוח PDF/HTML יומי עם KPIs — אחוז דיוק, קווים בעייתיים, מגמות</a:t>
             </a:r>
           </a:p>
         </p:txBody>

</xml_diff>

<commit_message>
Update slide 3 with real technology icons + slide 14 future items
Co-Authored-By: Claude Opus 4.6 <noreply@anthropic.com>
</commit_message>
<xml_diff>
--- a/docs/Israel_Transit_Project_Presentation.pptx
+++ b/docs/Israel_Transit_Project_Presentation.pptx
@@ -10872,18 +10872,18 @@
         </p:nvSpPr>
         <p:spPr>
           <a:xfrm>
-            <a:off x="274320" y="1371600"/>
-            <a:ext cx="2560320" cy="4114800"/>
+            <a:off x="182880" y="1234440"/>
+            <a:ext cx="2606040" cy="4754880"/>
           </a:xfrm>
           <a:prstGeom prst="roundRect">
             <a:avLst/>
           </a:prstGeom>
           <a:solidFill>
-            <a:srgbClr val="F5F5F5"/>
+            <a:srgbClr val="E8F5E9"/>
           </a:solidFill>
-          <a:ln w="12700">
+          <a:ln w="19050">
             <a:solidFill>
-              <a:srgbClr val="4DD0E1"/>
+              <a:srgbClr val="66BB6A"/>
             </a:solidFill>
           </a:ln>
         </p:spPr>
@@ -10917,8 +10917,8 @@
         </p:nvSpPr>
         <p:spPr>
           <a:xfrm>
-            <a:off x="365760" y="1463040"/>
-            <a:ext cx="2377440" cy="457200"/>
+            <a:off x="182880" y="1371600"/>
+            <a:ext cx="2606040" cy="365760"/>
           </a:xfrm>
           <a:prstGeom prst="rect">
             <a:avLst/>
@@ -10932,7 +10932,7 @@
           <a:lstStyle/>
           <a:p>
             <a:pPr algn="ctr">
-              <a:defRPr sz="1400" b="1">
+              <a:defRPr sz="1600" b="1">
                 <a:solidFill>
                   <a:srgbClr val="007B83"/>
                 </a:solidFill>
@@ -10940,7 +10940,7 @@
               </a:defRPr>
             </a:pPr>
             <a:r>
-              <a:t>📡 מקור הנתונים</a:t>
+              <a:t>מקור הנתונים</a:t>
             </a:r>
           </a:p>
         </p:txBody>
@@ -10953,8 +10953,8 @@
         </p:nvSpPr>
         <p:spPr>
           <a:xfrm>
-            <a:off x="365760" y="1874519"/>
-            <a:ext cx="2377440" cy="274320"/>
+            <a:off x="182880" y="1691640"/>
+            <a:ext cx="2606040" cy="274320"/>
           </a:xfrm>
           <a:prstGeom prst="rect">
             <a:avLst/>
@@ -10983,69 +10983,23 @@
       </p:sp>
       <p:sp>
         <p:nvSpPr>
-          <p:cNvPr id="9" name="TextBox 8"/>
-          <p:cNvSpPr txBox="1"/>
-          <p:nvPr/>
-        </p:nvSpPr>
-        <p:spPr>
-          <a:xfrm>
-            <a:off x="365760" y="2286000"/>
-            <a:ext cx="2377440" cy="2926080"/>
-          </a:xfrm>
-          <a:prstGeom prst="rect">
-            <a:avLst/>
-          </a:prstGeom>
-          <a:noFill/>
-        </p:spPr>
-        <p:txBody>
-          <a:bodyPr wrap="square">
-            <a:spAutoFit/>
-          </a:bodyPr>
-          <a:lstStyle/>
-          <a:p>
-            <a:pPr algn="ctr">
-              <a:defRPr sz="1200" b="0">
-                <a:solidFill>
-                  <a:srgbClr val="333333"/>
-                </a:solidFill>
-                <a:latin typeface="Arial"/>
-              </a:defRPr>
-            </a:pPr>
-            <a:r>
-              <a:t>Open Bus Stride (Hasadna)</a:t>
-            </a:r>
-            <a:br/>
-            <a:r>
-              <a:t>MOT GTFS-RT</a:t>
-            </a:r>
-            <a:br/>
-            <a:r>
-              <a:t>HERE Traffic API</a:t>
-            </a:r>
-          </a:p>
-        </p:txBody>
-      </p:sp>
-      <p:sp>
-        <p:nvSpPr>
-          <p:cNvPr id="10" name="Rounded Rectangle 9"/>
+          <p:cNvPr id="9" name="Rectangle 8"/>
           <p:cNvSpPr/>
           <p:nvPr/>
         </p:nvSpPr>
         <p:spPr>
           <a:xfrm>
-            <a:off x="3017520" y="1371600"/>
-            <a:ext cx="2560320" cy="4114800"/>
-          </a:xfrm>
-          <a:prstGeom prst="roundRect">
+            <a:off x="457200" y="2011680"/>
+            <a:ext cx="2057400" cy="18288"/>
+          </a:xfrm>
+          <a:prstGeom prst="rect">
             <a:avLst/>
           </a:prstGeom>
           <a:solidFill>
-            <a:srgbClr val="F5F5F5"/>
+            <a:srgbClr val="66BB6A"/>
           </a:solidFill>
-          <a:ln w="12700">
-            <a:solidFill>
-              <a:srgbClr val="4DD0E1"/>
-            </a:solidFill>
+          <a:ln>
+            <a:noFill/>
           </a:ln>
         </p:spPr>
         <p:style>
@@ -11070,6 +11024,30 @@
           </a:p>
         </p:txBody>
       </p:sp>
+      <p:pic>
+        <p:nvPicPr>
+          <p:cNvPr id="10" name="Picture 9" descr="PTrashut.svg.png"/>
+          <p:cNvPicPr>
+            <a:picLocks noChangeAspect="1"/>
+          </p:cNvPicPr>
+          <p:nvPr/>
+        </p:nvPicPr>
+        <p:blipFill>
+          <a:blip r:embed="rId2"/>
+          <a:stretch>
+            <a:fillRect/>
+          </a:stretch>
+        </p:blipFill>
+        <p:spPr>
+          <a:xfrm>
+            <a:off x="1234440" y="2240280"/>
+            <a:ext cx="502920" cy="502920"/>
+          </a:xfrm>
+          <a:prstGeom prst="rect">
+            <a:avLst/>
+          </a:prstGeom>
+        </p:spPr>
+      </p:pic>
       <p:sp>
         <p:nvSpPr>
           <p:cNvPr id="11" name="TextBox 10"/>
@@ -11078,8 +11056,8 @@
         </p:nvSpPr>
         <p:spPr>
           <a:xfrm>
-            <a:off x="3108960" y="1463040"/>
-            <a:ext cx="2377440" cy="457200"/>
+            <a:off x="274320" y="2788920"/>
+            <a:ext cx="2423160" cy="502920"/>
           </a:xfrm>
           <a:prstGeom prst="rect">
             <a:avLst/>
@@ -11093,29 +11071,57 @@
           <a:lstStyle/>
           <a:p>
             <a:pPr algn="ctr">
-              <a:defRPr sz="1400" b="1">
-                <a:solidFill>
-                  <a:srgbClr val="007B83"/>
-                </a:solidFill>
-                <a:latin typeface="Arial"/>
-              </a:defRPr>
-            </a:pPr>
-            <a:r>
-              <a:t>🔄 שכבת ייבוא</a:t>
-            </a:r>
-          </a:p>
-        </p:txBody>
-      </p:sp>
-      <p:sp>
-        <p:nvSpPr>
-          <p:cNvPr id="12" name="TextBox 11"/>
-          <p:cNvSpPr txBox="1"/>
-          <p:nvPr/>
-        </p:nvSpPr>
-        <p:spPr>
-          <a:xfrm>
-            <a:off x="3108960" y="1874519"/>
-            <a:ext cx="2377440" cy="274320"/>
+              <a:defRPr sz="1000" b="1">
+                <a:solidFill>
+                  <a:srgbClr val="333333"/>
+                </a:solidFill>
+                <a:latin typeface="Arial"/>
+              </a:defRPr>
+            </a:pPr>
+            <a:r>
+              <a:t>Open Bus Stride</a:t>
+            </a:r>
+            <a:br/>
+            <a:r>
+              <a:t>(Hasadna)</a:t>
+            </a:r>
+          </a:p>
+        </p:txBody>
+      </p:sp>
+      <p:pic>
+        <p:nvPicPr>
+          <p:cNvPr id="12" name="Picture 11" descr="PTrashut.svg.png"/>
+          <p:cNvPicPr>
+            <a:picLocks noChangeAspect="1"/>
+          </p:cNvPicPr>
+          <p:nvPr/>
+        </p:nvPicPr>
+        <p:blipFill>
+          <a:blip r:embed="rId2"/>
+          <a:stretch>
+            <a:fillRect/>
+          </a:stretch>
+        </p:blipFill>
+        <p:spPr>
+          <a:xfrm>
+            <a:off x="1234440" y="3474720"/>
+            <a:ext cx="502920" cy="502920"/>
+          </a:xfrm>
+          <a:prstGeom prst="rect">
+            <a:avLst/>
+          </a:prstGeom>
+        </p:spPr>
+      </p:pic>
+      <p:sp>
+        <p:nvSpPr>
+          <p:cNvPr id="13" name="TextBox 12"/>
+          <p:cNvSpPr txBox="1"/>
+          <p:nvPr/>
+        </p:nvSpPr>
+        <p:spPr>
+          <a:xfrm>
+            <a:off x="274320" y="4023360"/>
+            <a:ext cx="2423160" cy="502920"/>
           </a:xfrm>
           <a:prstGeom prst="rect">
             <a:avLst/>
@@ -11129,29 +11135,57 @@
           <a:lstStyle/>
           <a:p>
             <a:pPr algn="ctr">
-              <a:defRPr sz="1000" b="0">
-                <a:solidFill>
-                  <a:srgbClr val="666666"/>
-                </a:solidFill>
-                <a:latin typeface="Arial"/>
-              </a:defRPr>
-            </a:pPr>
-            <a:r>
-              <a:t>Ingestion Layer</a:t>
-            </a:r>
-          </a:p>
-        </p:txBody>
-      </p:sp>
-      <p:sp>
-        <p:nvSpPr>
-          <p:cNvPr id="13" name="TextBox 12"/>
-          <p:cNvSpPr txBox="1"/>
-          <p:nvPr/>
-        </p:nvSpPr>
-        <p:spPr>
-          <a:xfrm>
-            <a:off x="3108960" y="2286000"/>
-            <a:ext cx="2377440" cy="2926080"/>
+              <a:defRPr sz="1000" b="1">
+                <a:solidFill>
+                  <a:srgbClr val="333333"/>
+                </a:solidFill>
+                <a:latin typeface="Arial"/>
+              </a:defRPr>
+            </a:pPr>
+            <a:r>
+              <a:t>MOT GTFS-RT</a:t>
+            </a:r>
+            <a:br/>
+            <a:r>
+              <a:t>(משרד התחבורה)</a:t>
+            </a:r>
+          </a:p>
+        </p:txBody>
+      </p:sp>
+      <p:pic>
+        <p:nvPicPr>
+          <p:cNvPr id="14" name="Picture 13" descr="here.png"/>
+          <p:cNvPicPr>
+            <a:picLocks noChangeAspect="1"/>
+          </p:cNvPicPr>
+          <p:nvPr/>
+        </p:nvPicPr>
+        <p:blipFill>
+          <a:blip r:embed="rId3"/>
+          <a:stretch>
+            <a:fillRect/>
+          </a:stretch>
+        </p:blipFill>
+        <p:spPr>
+          <a:xfrm>
+            <a:off x="1234440" y="4709160"/>
+            <a:ext cx="502920" cy="502920"/>
+          </a:xfrm>
+          <a:prstGeom prst="rect">
+            <a:avLst/>
+          </a:prstGeom>
+        </p:spPr>
+      </p:pic>
+      <p:sp>
+        <p:nvSpPr>
+          <p:cNvPr id="15" name="TextBox 14"/>
+          <p:cNvSpPr txBox="1"/>
+          <p:nvPr/>
+        </p:nvSpPr>
+        <p:spPr>
+          <a:xfrm>
+            <a:off x="274320" y="5257800"/>
+            <a:ext cx="2423160" cy="502920"/>
           </a:xfrm>
           <a:prstGeom prst="rect">
             <a:avLst/>
@@ -11165,7 +11199,7 @@
           <a:lstStyle/>
           <a:p>
             <a:pPr algn="ctr">
-              <a:defRPr sz="1200" b="0">
+              <a:defRPr sz="1000" b="1">
                 <a:solidFill>
                   <a:srgbClr val="333333"/>
                 </a:solidFill>
@@ -11173,43 +11207,71 @@
               </a:defRPr>
             </a:pPr>
             <a:r>
-              <a:t>Apache Kafka — 9 topics</a:t>
+              <a:t>HERE Traffic</a:t>
             </a:r>
             <a:br/>
             <a:r>
-              <a:t>Apache Airflow — 6 DAGs</a:t>
-            </a:r>
-            <a:br/>
-            <a:r>
-              <a:t>Python Producers</a:t>
-            </a:r>
-            <a:br/>
-            <a:r>
-              <a:t>Cron Pipeline + Watchdog</a:t>
-            </a:r>
-          </a:p>
-        </p:txBody>
-      </p:sp>
-      <p:sp>
-        <p:nvSpPr>
-          <p:cNvPr id="14" name="Rounded Rectangle 13"/>
+              <a:t>API v7</a:t>
+            </a:r>
+          </a:p>
+        </p:txBody>
+      </p:sp>
+      <p:sp>
+        <p:nvSpPr>
+          <p:cNvPr id="16" name="TextBox 15"/>
+          <p:cNvSpPr txBox="1"/>
+          <p:nvPr/>
+        </p:nvSpPr>
+        <p:spPr>
+          <a:xfrm>
+            <a:off x="2807208" y="3337560"/>
+            <a:ext cx="228600" cy="457200"/>
+          </a:xfrm>
+          <a:prstGeom prst="rect">
+            <a:avLst/>
+          </a:prstGeom>
+          <a:noFill/>
+        </p:spPr>
+        <p:txBody>
+          <a:bodyPr wrap="square">
+            <a:spAutoFit/>
+          </a:bodyPr>
+          <a:lstStyle/>
+          <a:p>
+            <a:pPr algn="ctr">
+              <a:defRPr sz="2600" b="1">
+                <a:solidFill>
+                  <a:srgbClr val="009BA4"/>
+                </a:solidFill>
+                <a:latin typeface="Arial"/>
+              </a:defRPr>
+            </a:pPr>
+            <a:r>
+              <a:t>→</a:t>
+            </a:r>
+          </a:p>
+        </p:txBody>
+      </p:sp>
+      <p:sp>
+        <p:nvSpPr>
+          <p:cNvPr id="17" name="Rounded Rectangle 16"/>
           <p:cNvSpPr/>
           <p:nvPr/>
         </p:nvSpPr>
         <p:spPr>
           <a:xfrm>
-            <a:off x="5760720" y="1371600"/>
-            <a:ext cx="2560320" cy="4114800"/>
+            <a:off x="3017520" y="1234440"/>
+            <a:ext cx="2606040" cy="4754880"/>
           </a:xfrm>
           <a:prstGeom prst="roundRect">
             <a:avLst/>
           </a:prstGeom>
           <a:solidFill>
-            <a:srgbClr val="F5F5F5"/>
+            <a:srgbClr val="E3F2FD"/>
           </a:solidFill>
-          <a:ln w="12700">
+          <a:ln w="19050">
             <a:solidFill>
-              <a:srgbClr val="4DD0E1"/>
+              <a:srgbClr val="42A5F5"/>
             </a:solidFill>
           </a:ln>
         </p:spPr>
@@ -11237,14 +11299,14 @@
       </p:sp>
       <p:sp>
         <p:nvSpPr>
-          <p:cNvPr id="15" name="TextBox 14"/>
-          <p:cNvSpPr txBox="1"/>
-          <p:nvPr/>
-        </p:nvSpPr>
-        <p:spPr>
-          <a:xfrm>
-            <a:off x="5852160" y="1463040"/>
-            <a:ext cx="2377440" cy="457200"/>
+          <p:cNvPr id="18" name="TextBox 17"/>
+          <p:cNvSpPr txBox="1"/>
+          <p:nvPr/>
+        </p:nvSpPr>
+        <p:spPr>
+          <a:xfrm>
+            <a:off x="3017520" y="1371600"/>
+            <a:ext cx="2606040" cy="365760"/>
           </a:xfrm>
           <a:prstGeom prst="rect">
             <a:avLst/>
@@ -11258,7 +11320,7 @@
           <a:lstStyle/>
           <a:p>
             <a:pPr algn="ctr">
-              <a:defRPr sz="1400" b="1">
+              <a:defRPr sz="1600" b="1">
                 <a:solidFill>
                   <a:srgbClr val="007B83"/>
                 </a:solidFill>
@@ -11266,21 +11328,21 @@
               </a:defRPr>
             </a:pPr>
             <a:r>
-              <a:t>💾 שכבת אחסון</a:t>
-            </a:r>
-          </a:p>
-        </p:txBody>
-      </p:sp>
-      <p:sp>
-        <p:nvSpPr>
-          <p:cNvPr id="16" name="TextBox 15"/>
-          <p:cNvSpPr txBox="1"/>
-          <p:nvPr/>
-        </p:nvSpPr>
-        <p:spPr>
-          <a:xfrm>
-            <a:off x="5852160" y="1874519"/>
-            <a:ext cx="2377440" cy="274320"/>
+              <a:t>שכבת ייבוא</a:t>
+            </a:r>
+          </a:p>
+        </p:txBody>
+      </p:sp>
+      <p:sp>
+        <p:nvSpPr>
+          <p:cNvPr id="19" name="TextBox 18"/>
+          <p:cNvSpPr txBox="1"/>
+          <p:nvPr/>
+        </p:nvSpPr>
+        <p:spPr>
+          <a:xfrm>
+            <a:off x="3017520" y="1691640"/>
+            <a:ext cx="2606040" cy="274320"/>
           </a:xfrm>
           <a:prstGeom prst="rect">
             <a:avLst/>
@@ -11302,80 +11364,30 @@
               </a:defRPr>
             </a:pPr>
             <a:r>
-              <a:t>Storage Layer</a:t>
-            </a:r>
-          </a:p>
-        </p:txBody>
-      </p:sp>
-      <p:sp>
-        <p:nvSpPr>
-          <p:cNvPr id="17" name="TextBox 16"/>
-          <p:cNvSpPr txBox="1"/>
-          <p:nvPr/>
-        </p:nvSpPr>
-        <p:spPr>
-          <a:xfrm>
-            <a:off x="5852160" y="2286000"/>
-            <a:ext cx="2377440" cy="2926080"/>
-          </a:xfrm>
-          <a:prstGeom prst="rect">
-            <a:avLst/>
-          </a:prstGeom>
-          <a:noFill/>
-        </p:spPr>
-        <p:txBody>
-          <a:bodyPr wrap="square">
-            <a:spAutoFit/>
-          </a:bodyPr>
-          <a:lstStyle/>
-          <a:p>
-            <a:pPr algn="ctr">
-              <a:defRPr sz="1200" b="0">
-                <a:solidFill>
-                  <a:srgbClr val="333333"/>
-                </a:solidFill>
-                <a:latin typeface="Arial"/>
-              </a:defRPr>
-            </a:pPr>
-            <a:r>
-              <a:t>MinIO — Data Lake (raw JSON)</a:t>
-            </a:r>
-            <a:br/>
-            <a:r>
-              <a:t>Elasticsearch — searchable index</a:t>
-            </a:r>
-            <a:br/>
-            <a:r>
-              <a:t>PostgreSQL — GTFS static</a:t>
-            </a:r>
-            <a:br/>
-            <a:r>
-              <a:t>Local Buffer — Store &amp; Forward</a:t>
-            </a:r>
-          </a:p>
-        </p:txBody>
-      </p:sp>
-      <p:sp>
-        <p:nvSpPr>
-          <p:cNvPr id="18" name="Rounded Rectangle 17"/>
+              <a:t>Ingestion Layer</a:t>
+            </a:r>
+          </a:p>
+        </p:txBody>
+      </p:sp>
+      <p:sp>
+        <p:nvSpPr>
+          <p:cNvPr id="20" name="Rectangle 19"/>
           <p:cNvSpPr/>
           <p:nvPr/>
         </p:nvSpPr>
         <p:spPr>
           <a:xfrm>
-            <a:off x="8503920" y="1371600"/>
-            <a:ext cx="2560320" cy="4114800"/>
-          </a:xfrm>
-          <a:prstGeom prst="roundRect">
+            <a:off x="3291840" y="2011680"/>
+            <a:ext cx="2057400" cy="18288"/>
+          </a:xfrm>
+          <a:prstGeom prst="rect">
             <a:avLst/>
           </a:prstGeom>
           <a:solidFill>
-            <a:srgbClr val="F5F5F5"/>
+            <a:srgbClr val="42A5F5"/>
           </a:solidFill>
-          <a:ln w="12700">
-            <a:solidFill>
-              <a:srgbClr val="4DD0E1"/>
-            </a:solidFill>
+          <a:ln>
+            <a:noFill/>
           </a:ln>
         </p:spPr>
         <p:style>
@@ -11400,16 +11412,40 @@
           </a:p>
         </p:txBody>
       </p:sp>
-      <p:sp>
-        <p:nvSpPr>
-          <p:cNvPr id="19" name="TextBox 18"/>
-          <p:cNvSpPr txBox="1"/>
-          <p:nvPr/>
-        </p:nvSpPr>
-        <p:spPr>
-          <a:xfrm>
-            <a:off x="8595360" y="1463040"/>
-            <a:ext cx="2377440" cy="457200"/>
+      <p:pic>
+        <p:nvPicPr>
+          <p:cNvPr id="21" name="Picture 20" descr="apache.png"/>
+          <p:cNvPicPr>
+            <a:picLocks noChangeAspect="1"/>
+          </p:cNvPicPr>
+          <p:nvPr/>
+        </p:nvPicPr>
+        <p:blipFill>
+          <a:blip r:embed="rId4"/>
+          <a:stretch>
+            <a:fillRect/>
+          </a:stretch>
+        </p:blipFill>
+        <p:spPr>
+          <a:xfrm>
+            <a:off x="4069080" y="2240280"/>
+            <a:ext cx="502920" cy="502920"/>
+          </a:xfrm>
+          <a:prstGeom prst="rect">
+            <a:avLst/>
+          </a:prstGeom>
+        </p:spPr>
+      </p:pic>
+      <p:sp>
+        <p:nvSpPr>
+          <p:cNvPr id="22" name="TextBox 21"/>
+          <p:cNvSpPr txBox="1"/>
+          <p:nvPr/>
+        </p:nvSpPr>
+        <p:spPr>
+          <a:xfrm>
+            <a:off x="3108960" y="2788920"/>
+            <a:ext cx="2423160" cy="502920"/>
           </a:xfrm>
           <a:prstGeom prst="rect">
             <a:avLst/>
@@ -11423,7 +11459,256 @@
           <a:lstStyle/>
           <a:p>
             <a:pPr algn="ctr">
-              <a:defRPr sz="1400" b="1">
+              <a:defRPr sz="1000" b="1">
+                <a:solidFill>
+                  <a:srgbClr val="333333"/>
+                </a:solidFill>
+                <a:latin typeface="Arial"/>
+              </a:defRPr>
+            </a:pPr>
+            <a:r>
+              <a:t>Apache Kafka</a:t>
+            </a:r>
+            <a:br/>
+            <a:r>
+              <a:t>9 Topics</a:t>
+            </a:r>
+          </a:p>
+        </p:txBody>
+      </p:sp>
+      <p:pic>
+        <p:nvPicPr>
+          <p:cNvPr id="23" name="Picture 22" descr="apache-airflow.png"/>
+          <p:cNvPicPr>
+            <a:picLocks noChangeAspect="1"/>
+          </p:cNvPicPr>
+          <p:nvPr/>
+        </p:nvPicPr>
+        <p:blipFill>
+          <a:blip r:embed="rId5"/>
+          <a:stretch>
+            <a:fillRect/>
+          </a:stretch>
+        </p:blipFill>
+        <p:spPr>
+          <a:xfrm>
+            <a:off x="4069080" y="3474720"/>
+            <a:ext cx="502920" cy="502920"/>
+          </a:xfrm>
+          <a:prstGeom prst="rect">
+            <a:avLst/>
+          </a:prstGeom>
+        </p:spPr>
+      </p:pic>
+      <p:sp>
+        <p:nvSpPr>
+          <p:cNvPr id="24" name="TextBox 23"/>
+          <p:cNvSpPr txBox="1"/>
+          <p:nvPr/>
+        </p:nvSpPr>
+        <p:spPr>
+          <a:xfrm>
+            <a:off x="3108960" y="4023360"/>
+            <a:ext cx="2423160" cy="502920"/>
+          </a:xfrm>
+          <a:prstGeom prst="rect">
+            <a:avLst/>
+          </a:prstGeom>
+          <a:noFill/>
+        </p:spPr>
+        <p:txBody>
+          <a:bodyPr wrap="square">
+            <a:spAutoFit/>
+          </a:bodyPr>
+          <a:lstStyle/>
+          <a:p>
+            <a:pPr algn="ctr">
+              <a:defRPr sz="1000" b="1">
+                <a:solidFill>
+                  <a:srgbClr val="333333"/>
+                </a:solidFill>
+                <a:latin typeface="Arial"/>
+              </a:defRPr>
+            </a:pPr>
+            <a:r>
+              <a:t>Apache Airflow</a:t>
+            </a:r>
+            <a:br/>
+            <a:r>
+              <a:t>6 DAGs</a:t>
+            </a:r>
+          </a:p>
+        </p:txBody>
+      </p:sp>
+      <p:pic>
+        <p:nvPicPr>
+          <p:cNvPr id="25" name="Picture 24" descr="python.png"/>
+          <p:cNvPicPr>
+            <a:picLocks noChangeAspect="1"/>
+          </p:cNvPicPr>
+          <p:nvPr/>
+        </p:nvPicPr>
+        <p:blipFill>
+          <a:blip r:embed="rId6"/>
+          <a:stretch>
+            <a:fillRect/>
+          </a:stretch>
+        </p:blipFill>
+        <p:spPr>
+          <a:xfrm>
+            <a:off x="4069080" y="4709160"/>
+            <a:ext cx="502920" cy="502920"/>
+          </a:xfrm>
+          <a:prstGeom prst="rect">
+            <a:avLst/>
+          </a:prstGeom>
+        </p:spPr>
+      </p:pic>
+      <p:sp>
+        <p:nvSpPr>
+          <p:cNvPr id="26" name="TextBox 25"/>
+          <p:cNvSpPr txBox="1"/>
+          <p:nvPr/>
+        </p:nvSpPr>
+        <p:spPr>
+          <a:xfrm>
+            <a:off x="3108960" y="5257800"/>
+            <a:ext cx="2423160" cy="502920"/>
+          </a:xfrm>
+          <a:prstGeom prst="rect">
+            <a:avLst/>
+          </a:prstGeom>
+          <a:noFill/>
+        </p:spPr>
+        <p:txBody>
+          <a:bodyPr wrap="square">
+            <a:spAutoFit/>
+          </a:bodyPr>
+          <a:lstStyle/>
+          <a:p>
+            <a:pPr algn="ctr">
+              <a:defRPr sz="1000" b="1">
+                <a:solidFill>
+                  <a:srgbClr val="333333"/>
+                </a:solidFill>
+                <a:latin typeface="Arial"/>
+              </a:defRPr>
+            </a:pPr>
+            <a:r>
+              <a:t>Python Producers</a:t>
+            </a:r>
+            <a:br/>
+            <a:r>
+              <a:t>+ Cron Pipeline</a:t>
+            </a:r>
+          </a:p>
+        </p:txBody>
+      </p:sp>
+      <p:sp>
+        <p:nvSpPr>
+          <p:cNvPr id="27" name="TextBox 26"/>
+          <p:cNvSpPr txBox="1"/>
+          <p:nvPr/>
+        </p:nvSpPr>
+        <p:spPr>
+          <a:xfrm>
+            <a:off x="5641848" y="3337560"/>
+            <a:ext cx="228600" cy="457200"/>
+          </a:xfrm>
+          <a:prstGeom prst="rect">
+            <a:avLst/>
+          </a:prstGeom>
+          <a:noFill/>
+        </p:spPr>
+        <p:txBody>
+          <a:bodyPr wrap="square">
+            <a:spAutoFit/>
+          </a:bodyPr>
+          <a:lstStyle/>
+          <a:p>
+            <a:pPr algn="ctr">
+              <a:defRPr sz="2600" b="1">
+                <a:solidFill>
+                  <a:srgbClr val="009BA4"/>
+                </a:solidFill>
+                <a:latin typeface="Arial"/>
+              </a:defRPr>
+            </a:pPr>
+            <a:r>
+              <a:t>→</a:t>
+            </a:r>
+          </a:p>
+        </p:txBody>
+      </p:sp>
+      <p:sp>
+        <p:nvSpPr>
+          <p:cNvPr id="28" name="Rounded Rectangle 27"/>
+          <p:cNvSpPr/>
+          <p:nvPr/>
+        </p:nvSpPr>
+        <p:spPr>
+          <a:xfrm>
+            <a:off x="5852160" y="1234440"/>
+            <a:ext cx="2606040" cy="4754880"/>
+          </a:xfrm>
+          <a:prstGeom prst="roundRect">
+            <a:avLst/>
+          </a:prstGeom>
+          <a:solidFill>
+            <a:srgbClr val="FEF3E0"/>
+          </a:solidFill>
+          <a:ln w="19050">
+            <a:solidFill>
+              <a:srgbClr val="FFA726"/>
+            </a:solidFill>
+          </a:ln>
+        </p:spPr>
+        <p:style>
+          <a:lnRef idx="1">
+            <a:schemeClr val="accent1"/>
+          </a:lnRef>
+          <a:fillRef idx="3">
+            <a:schemeClr val="accent1"/>
+          </a:fillRef>
+          <a:effectRef idx="2">
+            <a:schemeClr val="accent1"/>
+          </a:effectRef>
+          <a:fontRef idx="minor">
+            <a:schemeClr val="lt1"/>
+          </a:fontRef>
+        </p:style>
+        <p:txBody>
+          <a:bodyPr rtlCol="0" anchor="ctr"/>
+          <a:lstStyle/>
+          <a:p>
+            <a:pPr algn="ctr"/>
+          </a:p>
+        </p:txBody>
+      </p:sp>
+      <p:sp>
+        <p:nvSpPr>
+          <p:cNvPr id="29" name="TextBox 28"/>
+          <p:cNvSpPr txBox="1"/>
+          <p:nvPr/>
+        </p:nvSpPr>
+        <p:spPr>
+          <a:xfrm>
+            <a:off x="5852160" y="1371600"/>
+            <a:ext cx="2606040" cy="365760"/>
+          </a:xfrm>
+          <a:prstGeom prst="rect">
+            <a:avLst/>
+          </a:prstGeom>
+          <a:noFill/>
+        </p:spPr>
+        <p:txBody>
+          <a:bodyPr wrap="square">
+            <a:spAutoFit/>
+          </a:bodyPr>
+          <a:lstStyle/>
+          <a:p>
+            <a:pPr algn="ctr">
+              <a:defRPr sz="1600" b="1">
                 <a:solidFill>
                   <a:srgbClr val="007B83"/>
                 </a:solidFill>
@@ -11431,21 +11716,21 @@
               </a:defRPr>
             </a:pPr>
             <a:r>
-              <a:t>🖥️ שכבת הצגה</a:t>
-            </a:r>
-          </a:p>
-        </p:txBody>
-      </p:sp>
-      <p:sp>
-        <p:nvSpPr>
-          <p:cNvPr id="20" name="TextBox 19"/>
-          <p:cNvSpPr txBox="1"/>
-          <p:nvPr/>
-        </p:nvSpPr>
-        <p:spPr>
-          <a:xfrm>
-            <a:off x="8595360" y="1874519"/>
-            <a:ext cx="2377440" cy="274320"/>
+              <a:t>שכבת אחסון</a:t>
+            </a:r>
+          </a:p>
+        </p:txBody>
+      </p:sp>
+      <p:sp>
+        <p:nvSpPr>
+          <p:cNvPr id="30" name="TextBox 29"/>
+          <p:cNvSpPr txBox="1"/>
+          <p:nvPr/>
+        </p:nvSpPr>
+        <p:spPr>
+          <a:xfrm>
+            <a:off x="5852160" y="1691640"/>
+            <a:ext cx="2606040" cy="274320"/>
           </a:xfrm>
           <a:prstGeom prst="rect">
             <a:avLst/>
@@ -11467,6 +11752,394 @@
               </a:defRPr>
             </a:pPr>
             <a:r>
+              <a:t>Storage Layer</a:t>
+            </a:r>
+          </a:p>
+        </p:txBody>
+      </p:sp>
+      <p:sp>
+        <p:nvSpPr>
+          <p:cNvPr id="31" name="Rectangle 30"/>
+          <p:cNvSpPr/>
+          <p:nvPr/>
+        </p:nvSpPr>
+        <p:spPr>
+          <a:xfrm>
+            <a:off x="6126480" y="2011680"/>
+            <a:ext cx="2057400" cy="18288"/>
+          </a:xfrm>
+          <a:prstGeom prst="rect">
+            <a:avLst/>
+          </a:prstGeom>
+          <a:solidFill>
+            <a:srgbClr val="FFA726"/>
+          </a:solidFill>
+          <a:ln>
+            <a:noFill/>
+          </a:ln>
+        </p:spPr>
+        <p:style>
+          <a:lnRef idx="1">
+            <a:schemeClr val="accent1"/>
+          </a:lnRef>
+          <a:fillRef idx="3">
+            <a:schemeClr val="accent1"/>
+          </a:fillRef>
+          <a:effectRef idx="2">
+            <a:schemeClr val="accent1"/>
+          </a:effectRef>
+          <a:fontRef idx="minor">
+            <a:schemeClr val="lt1"/>
+          </a:fontRef>
+        </p:style>
+        <p:txBody>
+          <a:bodyPr rtlCol="0" anchor="ctr"/>
+          <a:lstStyle/>
+          <a:p>
+            <a:pPr algn="ctr"/>
+          </a:p>
+        </p:txBody>
+      </p:sp>
+      <p:pic>
+        <p:nvPicPr>
+          <p:cNvPr id="32" name="Picture 31" descr="minio-light.png"/>
+          <p:cNvPicPr>
+            <a:picLocks noChangeAspect="1"/>
+          </p:cNvPicPr>
+          <p:nvPr/>
+        </p:nvPicPr>
+        <p:blipFill>
+          <a:blip r:embed="rId7"/>
+          <a:stretch>
+            <a:fillRect/>
+          </a:stretch>
+        </p:blipFill>
+        <p:spPr>
+          <a:xfrm>
+            <a:off x="6903720" y="2240280"/>
+            <a:ext cx="502920" cy="502920"/>
+          </a:xfrm>
+          <a:prstGeom prst="rect">
+            <a:avLst/>
+          </a:prstGeom>
+        </p:spPr>
+      </p:pic>
+      <p:sp>
+        <p:nvSpPr>
+          <p:cNvPr id="33" name="TextBox 32"/>
+          <p:cNvSpPr txBox="1"/>
+          <p:nvPr/>
+        </p:nvSpPr>
+        <p:spPr>
+          <a:xfrm>
+            <a:off x="5943600" y="2788920"/>
+            <a:ext cx="2423160" cy="502920"/>
+          </a:xfrm>
+          <a:prstGeom prst="rect">
+            <a:avLst/>
+          </a:prstGeom>
+          <a:noFill/>
+        </p:spPr>
+        <p:txBody>
+          <a:bodyPr wrap="square">
+            <a:spAutoFit/>
+          </a:bodyPr>
+          <a:lstStyle/>
+          <a:p>
+            <a:pPr algn="ctr">
+              <a:defRPr sz="1000" b="1">
+                <a:solidFill>
+                  <a:srgbClr val="333333"/>
+                </a:solidFill>
+                <a:latin typeface="Arial"/>
+              </a:defRPr>
+            </a:pPr>
+            <a:r>
+              <a:t>MinIO</a:t>
+            </a:r>
+            <a:br/>
+            <a:r>
+              <a:t>Data Lake (S3)</a:t>
+            </a:r>
+          </a:p>
+        </p:txBody>
+      </p:sp>
+      <p:pic>
+        <p:nvPicPr>
+          <p:cNvPr id="34" name="Picture 33" descr="elasticsearch.png"/>
+          <p:cNvPicPr>
+            <a:picLocks noChangeAspect="1"/>
+          </p:cNvPicPr>
+          <p:nvPr/>
+        </p:nvPicPr>
+        <p:blipFill>
+          <a:blip r:embed="rId8"/>
+          <a:stretch>
+            <a:fillRect/>
+          </a:stretch>
+        </p:blipFill>
+        <p:spPr>
+          <a:xfrm>
+            <a:off x="6903720" y="3474720"/>
+            <a:ext cx="502920" cy="502920"/>
+          </a:xfrm>
+          <a:prstGeom prst="rect">
+            <a:avLst/>
+          </a:prstGeom>
+        </p:spPr>
+      </p:pic>
+      <p:sp>
+        <p:nvSpPr>
+          <p:cNvPr id="35" name="TextBox 34"/>
+          <p:cNvSpPr txBox="1"/>
+          <p:nvPr/>
+        </p:nvSpPr>
+        <p:spPr>
+          <a:xfrm>
+            <a:off x="5943600" y="4023360"/>
+            <a:ext cx="2423160" cy="502920"/>
+          </a:xfrm>
+          <a:prstGeom prst="rect">
+            <a:avLst/>
+          </a:prstGeom>
+          <a:noFill/>
+        </p:spPr>
+        <p:txBody>
+          <a:bodyPr wrap="square">
+            <a:spAutoFit/>
+          </a:bodyPr>
+          <a:lstStyle/>
+          <a:p>
+            <a:pPr algn="ctr">
+              <a:defRPr sz="1000" b="1">
+                <a:solidFill>
+                  <a:srgbClr val="333333"/>
+                </a:solidFill>
+                <a:latin typeface="Arial"/>
+              </a:defRPr>
+            </a:pPr>
+            <a:r>
+              <a:t>Elasticsearch</a:t>
+            </a:r>
+            <a:br/>
+            <a:r>
+              <a:t>Search Index</a:t>
+            </a:r>
+          </a:p>
+        </p:txBody>
+      </p:sp>
+      <p:pic>
+        <p:nvPicPr>
+          <p:cNvPr id="36" name="Picture 35" descr="pgadmin.png"/>
+          <p:cNvPicPr>
+            <a:picLocks noChangeAspect="1"/>
+          </p:cNvPicPr>
+          <p:nvPr/>
+        </p:nvPicPr>
+        <p:blipFill>
+          <a:blip r:embed="rId9"/>
+          <a:stretch>
+            <a:fillRect/>
+          </a:stretch>
+        </p:blipFill>
+        <p:spPr>
+          <a:xfrm>
+            <a:off x="6903720" y="4709160"/>
+            <a:ext cx="502920" cy="502920"/>
+          </a:xfrm>
+          <a:prstGeom prst="rect">
+            <a:avLst/>
+          </a:prstGeom>
+        </p:spPr>
+      </p:pic>
+      <p:sp>
+        <p:nvSpPr>
+          <p:cNvPr id="37" name="TextBox 36"/>
+          <p:cNvSpPr txBox="1"/>
+          <p:nvPr/>
+        </p:nvSpPr>
+        <p:spPr>
+          <a:xfrm>
+            <a:off x="5943600" y="5257800"/>
+            <a:ext cx="2423160" cy="502920"/>
+          </a:xfrm>
+          <a:prstGeom prst="rect">
+            <a:avLst/>
+          </a:prstGeom>
+          <a:noFill/>
+        </p:spPr>
+        <p:txBody>
+          <a:bodyPr wrap="square">
+            <a:spAutoFit/>
+          </a:bodyPr>
+          <a:lstStyle/>
+          <a:p>
+            <a:pPr algn="ctr">
+              <a:defRPr sz="1000" b="1">
+                <a:solidFill>
+                  <a:srgbClr val="333333"/>
+                </a:solidFill>
+                <a:latin typeface="Arial"/>
+              </a:defRPr>
+            </a:pPr>
+            <a:r>
+              <a:t>PostgreSQL</a:t>
+            </a:r>
+            <a:br/>
+            <a:r>
+              <a:t>GTFS Static</a:t>
+            </a:r>
+          </a:p>
+        </p:txBody>
+      </p:sp>
+      <p:sp>
+        <p:nvSpPr>
+          <p:cNvPr id="38" name="TextBox 37"/>
+          <p:cNvSpPr txBox="1"/>
+          <p:nvPr/>
+        </p:nvSpPr>
+        <p:spPr>
+          <a:xfrm>
+            <a:off x="8476488" y="3337560"/>
+            <a:ext cx="228600" cy="457200"/>
+          </a:xfrm>
+          <a:prstGeom prst="rect">
+            <a:avLst/>
+          </a:prstGeom>
+          <a:noFill/>
+        </p:spPr>
+        <p:txBody>
+          <a:bodyPr wrap="square">
+            <a:spAutoFit/>
+          </a:bodyPr>
+          <a:lstStyle/>
+          <a:p>
+            <a:pPr algn="ctr">
+              <a:defRPr sz="2600" b="1">
+                <a:solidFill>
+                  <a:srgbClr val="009BA4"/>
+                </a:solidFill>
+                <a:latin typeface="Arial"/>
+              </a:defRPr>
+            </a:pPr>
+            <a:r>
+              <a:t>→</a:t>
+            </a:r>
+          </a:p>
+        </p:txBody>
+      </p:sp>
+      <p:sp>
+        <p:nvSpPr>
+          <p:cNvPr id="39" name="Rounded Rectangle 38"/>
+          <p:cNvSpPr/>
+          <p:nvPr/>
+        </p:nvSpPr>
+        <p:spPr>
+          <a:xfrm>
+            <a:off x="8686800" y="1234440"/>
+            <a:ext cx="2606040" cy="4754880"/>
+          </a:xfrm>
+          <a:prstGeom prst="roundRect">
+            <a:avLst/>
+          </a:prstGeom>
+          <a:solidFill>
+            <a:srgbClr val="FCE4EC"/>
+          </a:solidFill>
+          <a:ln w="19050">
+            <a:solidFill>
+              <a:srgbClr val="EC407A"/>
+            </a:solidFill>
+          </a:ln>
+        </p:spPr>
+        <p:style>
+          <a:lnRef idx="1">
+            <a:schemeClr val="accent1"/>
+          </a:lnRef>
+          <a:fillRef idx="3">
+            <a:schemeClr val="accent1"/>
+          </a:fillRef>
+          <a:effectRef idx="2">
+            <a:schemeClr val="accent1"/>
+          </a:effectRef>
+          <a:fontRef idx="minor">
+            <a:schemeClr val="lt1"/>
+          </a:fontRef>
+        </p:style>
+        <p:txBody>
+          <a:bodyPr rtlCol="0" anchor="ctr"/>
+          <a:lstStyle/>
+          <a:p>
+            <a:pPr algn="ctr"/>
+          </a:p>
+        </p:txBody>
+      </p:sp>
+      <p:sp>
+        <p:nvSpPr>
+          <p:cNvPr id="40" name="TextBox 39"/>
+          <p:cNvSpPr txBox="1"/>
+          <p:nvPr/>
+        </p:nvSpPr>
+        <p:spPr>
+          <a:xfrm>
+            <a:off x="8686800" y="1371600"/>
+            <a:ext cx="2606040" cy="365760"/>
+          </a:xfrm>
+          <a:prstGeom prst="rect">
+            <a:avLst/>
+          </a:prstGeom>
+          <a:noFill/>
+        </p:spPr>
+        <p:txBody>
+          <a:bodyPr wrap="square">
+            <a:spAutoFit/>
+          </a:bodyPr>
+          <a:lstStyle/>
+          <a:p>
+            <a:pPr algn="ctr">
+              <a:defRPr sz="1600" b="1">
+                <a:solidFill>
+                  <a:srgbClr val="007B83"/>
+                </a:solidFill>
+                <a:latin typeface="Arial"/>
+              </a:defRPr>
+            </a:pPr>
+            <a:r>
+              <a:t>שכבת הצגה</a:t>
+            </a:r>
+          </a:p>
+        </p:txBody>
+      </p:sp>
+      <p:sp>
+        <p:nvSpPr>
+          <p:cNvPr id="41" name="TextBox 40"/>
+          <p:cNvSpPr txBox="1"/>
+          <p:nvPr/>
+        </p:nvSpPr>
+        <p:spPr>
+          <a:xfrm>
+            <a:off x="8686800" y="1691640"/>
+            <a:ext cx="2606040" cy="274320"/>
+          </a:xfrm>
+          <a:prstGeom prst="rect">
+            <a:avLst/>
+          </a:prstGeom>
+          <a:noFill/>
+        </p:spPr>
+        <p:txBody>
+          <a:bodyPr wrap="square">
+            <a:spAutoFit/>
+          </a:bodyPr>
+          <a:lstStyle/>
+          <a:p>
+            <a:pPr algn="ctr">
+              <a:defRPr sz="1000" b="0">
+                <a:solidFill>
+                  <a:srgbClr val="666666"/>
+                </a:solidFill>
+                <a:latin typeface="Arial"/>
+              </a:defRPr>
+            </a:pPr>
+            <a:r>
               <a:t>Presentation Layer</a:t>
             </a:r>
           </a:p>
@@ -11474,14 +12147,81 @@
       </p:sp>
       <p:sp>
         <p:nvSpPr>
-          <p:cNvPr id="21" name="TextBox 20"/>
-          <p:cNvSpPr txBox="1"/>
-          <p:nvPr/>
-        </p:nvSpPr>
-        <p:spPr>
-          <a:xfrm>
-            <a:off x="8595360" y="2286000"/>
-            <a:ext cx="2377440" cy="2926080"/>
+          <p:cNvPr id="42" name="Rectangle 41"/>
+          <p:cNvSpPr/>
+          <p:nvPr/>
+        </p:nvSpPr>
+        <p:spPr>
+          <a:xfrm>
+            <a:off x="8961120" y="2011680"/>
+            <a:ext cx="2057400" cy="18288"/>
+          </a:xfrm>
+          <a:prstGeom prst="rect">
+            <a:avLst/>
+          </a:prstGeom>
+          <a:solidFill>
+            <a:srgbClr val="EC407A"/>
+          </a:solidFill>
+          <a:ln>
+            <a:noFill/>
+          </a:ln>
+        </p:spPr>
+        <p:style>
+          <a:lnRef idx="1">
+            <a:schemeClr val="accent1"/>
+          </a:lnRef>
+          <a:fillRef idx="3">
+            <a:schemeClr val="accent1"/>
+          </a:fillRef>
+          <a:effectRef idx="2">
+            <a:schemeClr val="accent1"/>
+          </a:effectRef>
+          <a:fontRef idx="minor">
+            <a:schemeClr val="lt1"/>
+          </a:fontRef>
+        </p:style>
+        <p:txBody>
+          <a:bodyPr rtlCol="0" anchor="ctr"/>
+          <a:lstStyle/>
+          <a:p>
+            <a:pPr algn="ctr"/>
+          </a:p>
+        </p:txBody>
+      </p:sp>
+      <p:pic>
+        <p:nvPicPr>
+          <p:cNvPr id="43" name="Picture 42" descr="python.png"/>
+          <p:cNvPicPr>
+            <a:picLocks noChangeAspect="1"/>
+          </p:cNvPicPr>
+          <p:nvPr/>
+        </p:nvPicPr>
+        <p:blipFill>
+          <a:blip r:embed="rId6"/>
+          <a:stretch>
+            <a:fillRect/>
+          </a:stretch>
+        </p:blipFill>
+        <p:spPr>
+          <a:xfrm>
+            <a:off x="9738360" y="2240280"/>
+            <a:ext cx="502920" cy="502920"/>
+          </a:xfrm>
+          <a:prstGeom prst="rect">
+            <a:avLst/>
+          </a:prstGeom>
+        </p:spPr>
+      </p:pic>
+      <p:sp>
+        <p:nvSpPr>
+          <p:cNvPr id="44" name="TextBox 43"/>
+          <p:cNvSpPr txBox="1"/>
+          <p:nvPr/>
+        </p:nvSpPr>
+        <p:spPr>
+          <a:xfrm>
+            <a:off x="8778240" y="2788920"/>
+            <a:ext cx="2423160" cy="502920"/>
           </a:xfrm>
           <a:prstGeom prst="rect">
             <a:avLst/>
@@ -11495,7 +12235,7 @@
           <a:lstStyle/>
           <a:p>
             <a:pPr algn="ctr">
-              <a:defRPr sz="1200" b="0">
+              <a:defRPr sz="1000" b="1">
                 <a:solidFill>
                   <a:srgbClr val="333333"/>
                 </a:solidFill>
@@ -11503,127 +12243,139 @@
               </a:defRPr>
             </a:pPr>
             <a:r>
-              <a:t>Flask Bot (port 5000)</a:t>
+              <a:t>Flask Bot</a:t>
             </a:r>
             <a:br/>
             <a:r>
-              <a:t>Kibana Dashboards</a:t>
+              <a:t>port 5000 + PWA</a:t>
+            </a:r>
+          </a:p>
+        </p:txBody>
+      </p:sp>
+      <p:pic>
+        <p:nvPicPr>
+          <p:cNvPr id="45" name="Picture 44" descr="elastic-kibana.png"/>
+          <p:cNvPicPr>
+            <a:picLocks noChangeAspect="1"/>
+          </p:cNvPicPr>
+          <p:nvPr/>
+        </p:nvPicPr>
+        <p:blipFill>
+          <a:blip r:embed="rId10"/>
+          <a:stretch>
+            <a:fillRect/>
+          </a:stretch>
+        </p:blipFill>
+        <p:spPr>
+          <a:xfrm>
+            <a:off x="9738360" y="3474720"/>
+            <a:ext cx="502920" cy="502920"/>
+          </a:xfrm>
+          <a:prstGeom prst="rect">
+            <a:avLst/>
+          </a:prstGeom>
+        </p:spPr>
+      </p:pic>
+      <p:sp>
+        <p:nvSpPr>
+          <p:cNvPr id="46" name="TextBox 45"/>
+          <p:cNvSpPr txBox="1"/>
+          <p:nvPr/>
+        </p:nvSpPr>
+        <p:spPr>
+          <a:xfrm>
+            <a:off x="8778240" y="4023360"/>
+            <a:ext cx="2423160" cy="502920"/>
+          </a:xfrm>
+          <a:prstGeom prst="rect">
+            <a:avLst/>
+          </a:prstGeom>
+          <a:noFill/>
+        </p:spPr>
+        <p:txBody>
+          <a:bodyPr wrap="square">
+            <a:spAutoFit/>
+          </a:bodyPr>
+          <a:lstStyle/>
+          <a:p>
+            <a:pPr algn="ctr">
+              <a:defRPr sz="1000" b="1">
+                <a:solidFill>
+                  <a:srgbClr val="333333"/>
+                </a:solidFill>
+                <a:latin typeface="Arial"/>
+              </a:defRPr>
+            </a:pPr>
+            <a:r>
+              <a:t>Kibana</a:t>
             </a:r>
             <a:br/>
             <a:r>
-              <a:t>Gush Dan PWA (ניידית)</a:t>
+              <a:t>Dashboards</a:t>
+            </a:r>
+          </a:p>
+        </p:txBody>
+      </p:sp>
+      <p:pic>
+        <p:nvPicPr>
+          <p:cNvPr id="47" name="Picture 46" descr="naya transit.png"/>
+          <p:cNvPicPr>
+            <a:picLocks noChangeAspect="1"/>
+          </p:cNvPicPr>
+          <p:nvPr/>
+        </p:nvPicPr>
+        <p:blipFill>
+          <a:blip r:embed="rId11"/>
+          <a:stretch>
+            <a:fillRect/>
+          </a:stretch>
+        </p:blipFill>
+        <p:spPr>
+          <a:xfrm>
+            <a:off x="9738360" y="4709160"/>
+            <a:ext cx="502920" cy="502920"/>
+          </a:xfrm>
+          <a:prstGeom prst="rect">
+            <a:avLst/>
+          </a:prstGeom>
+        </p:spPr>
+      </p:pic>
+      <p:sp>
+        <p:nvSpPr>
+          <p:cNvPr id="48" name="TextBox 47"/>
+          <p:cNvSpPr txBox="1"/>
+          <p:nvPr/>
+        </p:nvSpPr>
+        <p:spPr>
+          <a:xfrm>
+            <a:off x="8778240" y="5257800"/>
+            <a:ext cx="2423160" cy="502920"/>
+          </a:xfrm>
+          <a:prstGeom prst="rect">
+            <a:avLst/>
+          </a:prstGeom>
+          <a:noFill/>
+        </p:spPr>
+        <p:txBody>
+          <a:bodyPr wrap="square">
+            <a:spAutoFit/>
+          </a:bodyPr>
+          <a:lstStyle/>
+          <a:p>
+            <a:pPr algn="ctr">
+              <a:defRPr sz="1000" b="1">
+                <a:solidFill>
+                  <a:srgbClr val="333333"/>
+                </a:solidFill>
+                <a:latin typeface="Arial"/>
+              </a:defRPr>
+            </a:pPr>
+            <a:r>
+              <a:t>Gush Dan App</a:t>
             </a:r>
             <a:br/>
             <a:r>
-              <a:t>ngrok — גישה מרחוק</a:t>
-            </a:r>
-          </a:p>
-        </p:txBody>
-      </p:sp>
-      <p:sp>
-        <p:nvSpPr>
-          <p:cNvPr id="22" name="TextBox 21"/>
-          <p:cNvSpPr txBox="1"/>
-          <p:nvPr/>
-        </p:nvSpPr>
-        <p:spPr>
-          <a:xfrm>
-            <a:off x="2880360" y="3017520"/>
-            <a:ext cx="274320" cy="457200"/>
-          </a:xfrm>
-          <a:prstGeom prst="rect">
-            <a:avLst/>
-          </a:prstGeom>
-          <a:noFill/>
-        </p:spPr>
-        <p:txBody>
-          <a:bodyPr wrap="square">
-            <a:spAutoFit/>
-          </a:bodyPr>
-          <a:lstStyle/>
-          <a:p>
-            <a:pPr algn="ctr">
-              <a:defRPr sz="2800" b="1">
-                <a:solidFill>
-                  <a:srgbClr val="009BA4"/>
-                </a:solidFill>
-                <a:latin typeface="Arial"/>
-              </a:defRPr>
-            </a:pPr>
-            <a:r>
-              <a:t>→</a:t>
-            </a:r>
-          </a:p>
-        </p:txBody>
-      </p:sp>
-      <p:sp>
-        <p:nvSpPr>
-          <p:cNvPr id="23" name="TextBox 22"/>
-          <p:cNvSpPr txBox="1"/>
-          <p:nvPr/>
-        </p:nvSpPr>
-        <p:spPr>
-          <a:xfrm>
-            <a:off x="5623560" y="3017520"/>
-            <a:ext cx="274320" cy="457200"/>
-          </a:xfrm>
-          <a:prstGeom prst="rect">
-            <a:avLst/>
-          </a:prstGeom>
-          <a:noFill/>
-        </p:spPr>
-        <p:txBody>
-          <a:bodyPr wrap="square">
-            <a:spAutoFit/>
-          </a:bodyPr>
-          <a:lstStyle/>
-          <a:p>
-            <a:pPr algn="ctr">
-              <a:defRPr sz="2800" b="1">
-                <a:solidFill>
-                  <a:srgbClr val="009BA4"/>
-                </a:solidFill>
-                <a:latin typeface="Arial"/>
-              </a:defRPr>
-            </a:pPr>
-            <a:r>
-              <a:t>→</a:t>
-            </a:r>
-          </a:p>
-        </p:txBody>
-      </p:sp>
-      <p:sp>
-        <p:nvSpPr>
-          <p:cNvPr id="24" name="TextBox 23"/>
-          <p:cNvSpPr txBox="1"/>
-          <p:nvPr/>
-        </p:nvSpPr>
-        <p:spPr>
-          <a:xfrm>
-            <a:off x="8366760" y="3017520"/>
-            <a:ext cx="274320" cy="457200"/>
-          </a:xfrm>
-          <a:prstGeom prst="rect">
-            <a:avLst/>
-          </a:prstGeom>
-          <a:noFill/>
-        </p:spPr>
-        <p:txBody>
-          <a:bodyPr wrap="square">
-            <a:spAutoFit/>
-          </a:bodyPr>
-          <a:lstStyle/>
-          <a:p>
-            <a:pPr algn="ctr">
-              <a:defRPr sz="2800" b="1">
-                <a:solidFill>
-                  <a:srgbClr val="009BA4"/>
-                </a:solidFill>
-                <a:latin typeface="Arial"/>
-              </a:defRPr>
-            </a:pPr>
-            <a:r>
-              <a:t>→</a:t>
+              <a:t>Moovit-style</a:t>
             </a:r>
           </a:p>
         </p:txBody>

</xml_diff>